<commit_message>
Revise Section 5: four-component problem-statement model (slides 23-26)
- Slide 23: replace Context/Relevance/Strategy funnel with the four-component
  reference table (Component | Purpose | Key Question It Answers)
- Slide 24: rebuild as 'One Sentence per Component' - scaffold sentences beside
  the finished, submission-ready combined paragraph (Example A / Zambales)
- Slide 25: pitfalls table now three columns (Pitfall | Missing Component | Fix)
- Slide 26: activity instruction and notes reframed around the four components
- Speaker notes updated on all revised slides
</commit_message>
<xml_diff>
--- a/Lecture3-Review-of-Literature.pptx
+++ b/Lecture3-Review-of-Literature.pptx
@@ -1685,13 +1685,13 @@
           <a:lstStyle/>
           <a:p>
             <a:r>
-              <a:t>Present this as a practical writing formula, not an abstract theory — students often freeze when told to "just write a problem statement," so giving them three concrete building blocks to write in sequence makes the task approachable. Note that this structure works whether the final study is fully quantitative or a quantitative-led mixed methods design.</a:t>
+              <a:t>Present this as the universal four-part anatomy of a problem statement — every effective research problem statement contains these four components in some form, regardless of field or format. Tell students a strong problem statement needs at least one full sentence per component — skipping any one of the four leaves the reader with an unanswered question: why does this setting matter (context)? what exactly is missing (gap)? who is affected if nothing changes (implications)? and what will this study actually do (objectives)? Note that these four components do the same job as a general "why this study matters" explanation, just broken into finer, checkable parts.</a:t>
             </a:r>
           </a:p>
           <a:p/>
           <a:p>
             <a:r>
-              <a:t>Visual: a funnel diagram narrowing from Context (widest) to Relevance to Strategy (narrowest), ending in a single problem-statement sentence.</a:t>
+              <a:t>Visual: a four-row reference table matching this exact structure, formatted so students can reuse it directly as a drafting template when writing their own problem statement.</a:t>
             </a:r>
           </a:p>
         </p:txBody>
@@ -1761,13 +1761,13 @@
           <a:lstStyle/>
           <a:p>
             <a:r>
-              <a:t>Read the final boxed statement aloud and ask students to identify which sentence came from Context, which from Relevance, and which from Strategy — this reverse-engineering check reinforces the formula. Note how directly this statement traces back to the Topic 3/Summary gap identified in Slide 18.</a:t>
+              <a:t>Build this slide sentence by sentence, revealing one component at a time, so students see the paragraph accumulate piece by piece rather than appearing all at once as a finished product. Point out that the finished paragraph reads as one natural piece of academic writing — the four components are a drafting scaffold, not four visibly separate boxes that must remain labeled in the final write-up. Note how directly the Specific Problem/Gap sentence traces back to the Topic 3/Summary gap identified back in Slide 18, and how the Objectives sentence will resurface almost unchanged as the general research question in the next section.</a:t>
             </a:r>
           </a:p>
           <a:p/>
           <a:p>
             <a:r>
-              <a:t>Visual: none additional beyond the highlighted final-statement box.</a:t>
+              <a:t>Visual: reveal the four labeled sentences in sequence (build animation), then highlight the final combined paragraph in a bordered box to show the finished, submission-ready product.</a:t>
             </a:r>
           </a:p>
         </p:txBody>
@@ -1837,13 +1837,13 @@
           <a:lstStyle/>
           <a:p>
             <a:r>
-              <a:t>Go through each pitfall using a "spot what's wrong" approach before revealing the fix — this keeps students actively diagnosing rather than passively reading. Connect the "merely descriptive" pitfall back to Slide 22's criteria: a true problem statement must show why something is unresolved, not just describe a situation.</a:t>
+              <a:t>Go through each pitfall using a "spot what's wrong" approach before revealing the fix — this keeps students actively diagnosing rather than passively reading. Reframe each pitfall as a missing component from Slide 23's four-part structure — editing becomes a checklist task ("which of the four parts is absent?") instead of a vague stylistic judgment.</a:t>
             </a:r>
           </a:p>
           <a:p/>
           <a:p>
             <a:r>
-              <a:t>Visual: none additional; the table's two-column contrast is sufficient.</a:t>
+              <a:t>Visual: none additional; the table's three-column structure is sufficient.</a:t>
             </a:r>
           </a:p>
         </p:txBody>
@@ -1913,7 +1913,7 @@
           <a:lstStyle/>
           <a:p>
             <a:r>
-              <a:t>Have students work in pairs to name which pitfall each statement falls into, then rewrite it using the Context–Relevance–Strategy formula from Slide 23. Circulate and prompt students who write a "fixed" version that is still too broad — a common second-round mistake.</a:t>
+              <a:t>Have students work in pairs to name which of the four components (Background Context, Specific Problem/Gap, Implications, Objectives/Aims) is missing from each statement, then rewrite it by adding at least one sentence for every component, following the model on Slide 24. Circulate and watch for a common second-round mistake: students patch one missing component but leave another one still absent.</a:t>
             </a:r>
           </a:p>
           <a:p/>
@@ -20638,13 +20638,13 @@
               </a:spcAft>
             </a:pPr>
             <a:r>
-              <a:rPr sz="2600" b="1" i="0">
+              <a:rPr sz="2700" b="1" i="0">
                 <a:solidFill>
                   <a:srgbClr val="14213D"/>
                 </a:solidFill>
                 <a:latin typeface="Segoe UI Semibold"/>
               </a:rPr>
-              <a:t>Three Building Blocks: Context, Relevance, Strategy</a:t>
+              <a:t>The Four Components of a Problem Statement</a:t>
             </a:r>
           </a:p>
         </p:txBody>
@@ -20802,294 +20802,491 @@
       </p:sp>
       <p:sp>
         <p:nvSpPr>
-          <p:cNvPr id="9" name="Rounded Rectangle 8"/>
-          <p:cNvSpPr/>
-          <p:nvPr/>
-        </p:nvSpPr>
-        <p:spPr>
-          <a:xfrm>
-            <a:off x="1249527" y="1874519"/>
-            <a:ext cx="9692640" cy="777240"/>
-          </a:xfrm>
-          <a:prstGeom prst="roundRect">
-            <a:avLst>
-              <a:gd name="adj" fmla="val 14000"/>
-            </a:avLst>
-          </a:prstGeom>
-          <a:solidFill>
-            <a:srgbClr val="1D7A8C"/>
-          </a:solidFill>
-          <a:ln>
-            <a:noFill/>
-          </a:ln>
-          <a:effectLst>
-            <a:outerShdw blurRad="127000" dist="63500" dir="5400000" rotWithShape="0">
-              <a:srgbClr val="1B2A3A">
-                <a:alpha val="24000"/>
-              </a:srgbClr>
-            </a:outerShdw>
-          </a:effectLst>
-        </p:spPr>
-        <p:style>
-          <a:lnRef idx="1">
-            <a:schemeClr val="accent1"/>
-          </a:lnRef>
-          <a:fillRef idx="3">
-            <a:schemeClr val="accent1"/>
-          </a:fillRef>
-          <a:effectRef idx="2">
-            <a:schemeClr val="accent1"/>
-          </a:effectRef>
-          <a:fontRef idx="minor">
-            <a:schemeClr val="lt1"/>
-          </a:fontRef>
-        </p:style>
-        <p:txBody>
-          <a:bodyPr rtlCol="0" anchor="ctr" wrap="square"/>
-          <a:lstStyle/>
-          <a:p>
-            <a:pPr algn="ctr">
+          <p:cNvPr id="9" name="TextBox 8"/>
+          <p:cNvSpPr txBox="1"/>
+          <p:nvPr/>
+        </p:nvSpPr>
+        <p:spPr>
+          <a:xfrm>
+            <a:off x="777240" y="1691639"/>
+            <a:ext cx="10637215" cy="292608"/>
+          </a:xfrm>
+          <a:prstGeom prst="rect">
+            <a:avLst/>
+          </a:prstGeom>
+          <a:noFill/>
+        </p:spPr>
+        <p:txBody>
+          <a:bodyPr wrap="square" anchor="t" lIns="0" rIns="0" tIns="0" bIns="0">
+            <a:spAutoFit/>
+          </a:bodyPr>
+          <a:lstStyle/>
+          <a:p>
+            <a:pPr algn="l">
               <a:lnSpc>
-                <a:spcPct val="100000"/>
+                <a:spcPct val="105000"/>
               </a:lnSpc>
-            </a:pPr>
-            <a:r>
-              <a:rPr sz="1900" b="1" i="0">
-                <a:solidFill>
-                  <a:srgbClr val="FFFFFF"/>
-                </a:solidFill>
-                <a:latin typeface="Segoe UI Semibold"/>
-              </a:rPr>
-              <a:t>Context  </a:t>
-            </a:r>
-            <a:r>
-              <a:rPr sz="1600" b="0" i="0">
-                <a:solidFill>
-                  <a:srgbClr val="EAF6F8"/>
-                </a:solidFill>
-                <a:latin typeface="Segoe UI"/>
-              </a:rPr>
-              <a:t>the background and current situation surrounding the issue</a:t>
-            </a:r>
-          </a:p>
-        </p:txBody>
-      </p:sp>
-      <p:sp>
-        <p:nvSpPr>
-          <p:cNvPr id="10" name="Rounded Rectangle 9"/>
-          <p:cNvSpPr/>
-          <p:nvPr/>
-        </p:nvSpPr>
-        <p:spPr>
-          <a:xfrm>
-            <a:off x="2163927" y="2798063"/>
-            <a:ext cx="7863840" cy="777240"/>
-          </a:xfrm>
-          <a:prstGeom prst="roundRect">
-            <a:avLst>
-              <a:gd name="adj" fmla="val 14000"/>
-            </a:avLst>
-          </a:prstGeom>
-          <a:solidFill>
-            <a:srgbClr val="F4795B"/>
-          </a:solidFill>
-          <a:ln>
-            <a:noFill/>
-          </a:ln>
-          <a:effectLst>
-            <a:outerShdw blurRad="127000" dist="63500" dir="5400000" rotWithShape="0">
-              <a:srgbClr val="1B2A3A">
-                <a:alpha val="24000"/>
-              </a:srgbClr>
-            </a:outerShdw>
-          </a:effectLst>
-        </p:spPr>
-        <p:style>
-          <a:lnRef idx="1">
-            <a:schemeClr val="accent1"/>
-          </a:lnRef>
-          <a:fillRef idx="3">
-            <a:schemeClr val="accent1"/>
-          </a:fillRef>
-          <a:effectRef idx="2">
-            <a:schemeClr val="accent1"/>
-          </a:effectRef>
-          <a:fontRef idx="minor">
-            <a:schemeClr val="lt1"/>
-          </a:fontRef>
-        </p:style>
-        <p:txBody>
-          <a:bodyPr rtlCol="0" anchor="ctr" wrap="square"/>
-          <a:lstStyle/>
-          <a:p>
-            <a:pPr algn="ctr">
-              <a:lnSpc>
-                <a:spcPct val="100000"/>
-              </a:lnSpc>
-            </a:pPr>
-            <a:r>
-              <a:rPr sz="1900" b="1" i="0">
-                <a:solidFill>
-                  <a:srgbClr val="FFFFFF"/>
-                </a:solidFill>
-                <a:latin typeface="Segoe UI Semibold"/>
-              </a:rPr>
-              <a:t>Relevance  </a:t>
-            </a:r>
-            <a:r>
-              <a:rPr sz="1600" b="0" i="0">
-                <a:solidFill>
-                  <a:srgbClr val="EAF6F8"/>
-                </a:solidFill>
-                <a:latin typeface="Segoe UI"/>
-              </a:rPr>
-              <a:t>why the issue matters, and who is affected if it stays unresolved</a:t>
-            </a:r>
-          </a:p>
-        </p:txBody>
-      </p:sp>
-      <p:sp>
-        <p:nvSpPr>
-          <p:cNvPr id="11" name="Rounded Rectangle 10"/>
-          <p:cNvSpPr/>
-          <p:nvPr/>
-        </p:nvSpPr>
-        <p:spPr>
-          <a:xfrm>
-            <a:off x="3078327" y="3721607"/>
-            <a:ext cx="6035040" cy="777240"/>
-          </a:xfrm>
-          <a:prstGeom prst="roundRect">
-            <a:avLst>
-              <a:gd name="adj" fmla="val 14000"/>
-            </a:avLst>
-          </a:prstGeom>
-          <a:solidFill>
-            <a:srgbClr val="2A9D8F"/>
-          </a:solidFill>
-          <a:ln>
-            <a:noFill/>
-          </a:ln>
-          <a:effectLst>
-            <a:outerShdw blurRad="127000" dist="63500" dir="5400000" rotWithShape="0">
-              <a:srgbClr val="1B2A3A">
-                <a:alpha val="24000"/>
-              </a:srgbClr>
-            </a:outerShdw>
-          </a:effectLst>
-        </p:spPr>
-        <p:style>
-          <a:lnRef idx="1">
-            <a:schemeClr val="accent1"/>
-          </a:lnRef>
-          <a:fillRef idx="3">
-            <a:schemeClr val="accent1"/>
-          </a:fillRef>
-          <a:effectRef idx="2">
-            <a:schemeClr val="accent1"/>
-          </a:effectRef>
-          <a:fontRef idx="minor">
-            <a:schemeClr val="lt1"/>
-          </a:fontRef>
-        </p:style>
-        <p:txBody>
-          <a:bodyPr rtlCol="0" anchor="ctr" wrap="square"/>
-          <a:lstStyle/>
-          <a:p>
-            <a:pPr algn="ctr">
-              <a:lnSpc>
-                <a:spcPct val="100000"/>
-              </a:lnSpc>
-            </a:pPr>
-            <a:r>
-              <a:rPr sz="1900" b="1" i="0">
-                <a:solidFill>
-                  <a:srgbClr val="FFFFFF"/>
-                </a:solidFill>
-                <a:latin typeface="Segoe UI Semibold"/>
-              </a:rPr>
-              <a:t>Strategy  </a:t>
-            </a:r>
-            <a:r>
-              <a:rPr sz="1600" b="0" i="0">
-                <a:solidFill>
-                  <a:srgbClr val="EAF6F8"/>
-                </a:solidFill>
-                <a:latin typeface="Segoe UI"/>
-              </a:rPr>
-              <a:t>the general goal and approach your study will take to address it</a:t>
-            </a:r>
-          </a:p>
-        </p:txBody>
-      </p:sp>
-      <p:sp>
-        <p:nvSpPr>
-          <p:cNvPr id="12" name="Rounded Rectangle 11"/>
-          <p:cNvSpPr/>
-          <p:nvPr/>
-        </p:nvSpPr>
-        <p:spPr>
-          <a:xfrm>
-            <a:off x="2438247" y="4709160"/>
-            <a:ext cx="7315200" cy="621792"/>
-          </a:xfrm>
-          <a:prstGeom prst="roundRect">
-            <a:avLst>
-              <a:gd name="adj" fmla="val 14000"/>
-            </a:avLst>
-          </a:prstGeom>
-          <a:solidFill>
-            <a:srgbClr val="14213D"/>
-          </a:solidFill>
-          <a:ln>
-            <a:noFill/>
-          </a:ln>
-          <a:effectLst>
-            <a:outerShdw blurRad="127000" dist="63500" dir="5400000" rotWithShape="0">
-              <a:srgbClr val="1B2A3A">
-                <a:alpha val="24000"/>
-              </a:srgbClr>
-            </a:outerShdw>
-          </a:effectLst>
-        </p:spPr>
-        <p:style>
-          <a:lnRef idx="1">
-            <a:schemeClr val="accent1"/>
-          </a:lnRef>
-          <a:fillRef idx="3">
-            <a:schemeClr val="accent1"/>
-          </a:fillRef>
-          <a:effectRef idx="2">
-            <a:schemeClr val="accent1"/>
-          </a:effectRef>
-          <a:fontRef idx="minor">
-            <a:schemeClr val="lt1"/>
-          </a:fontRef>
-        </p:style>
-        <p:txBody>
-          <a:bodyPr rtlCol="0" anchor="ctr" wrap="square" lIns="76200" rIns="76200" tIns="38100" bIns="38100"/>
-          <a:lstStyle/>
-          <a:p>
-            <a:pPr algn="ctr">
-              <a:lnSpc>
-                <a:spcPct val="100000"/>
-              </a:lnSpc>
+              <a:spcBef>
+                <a:spcPts val="0"/>
+              </a:spcBef>
               <a:spcAft>
                 <a:spcPts val="0"/>
               </a:spcAft>
             </a:pPr>
             <a:r>
-              <a:rPr sz="1650" b="1" i="0">
-                <a:solidFill>
-                  <a:srgbClr val="FFFFFF"/>
+              <a:rPr sz="1400" b="0" i="1">
+                <a:solidFill>
+                  <a:srgbClr val="5B6B7B"/>
                 </a:solidFill>
                 <a:latin typeface="Segoe UI"/>
               </a:rPr>
-              <a:t>↓  These three, written in order, build a complete problem statement</a:t>
-            </a:r>
-          </a:p>
-        </p:txBody>
-      </p:sp>
+              <a:t>A strong statement needs at least one full sentence per component.</a:t>
+            </a:r>
+          </a:p>
+        </p:txBody>
+      </p:sp>
+      <p:graphicFrame>
+        <p:nvGraphicFramePr>
+          <p:cNvPr id="10" name="Table 9"/>
+          <p:cNvGraphicFramePr>
+            <a:graphicFrameLocks noGrp="1"/>
+          </p:cNvGraphicFramePr>
+          <p:nvPr/>
+        </p:nvGraphicFramePr>
+        <p:xfrm>
+          <a:off x="777240" y="2084831"/>
+          <a:ext cx="10637213" cy="3794760"/>
+        </p:xfrm>
+        <a:graphic>
+          <a:graphicData uri="http://schemas.openxmlformats.org/drawingml/2006/table">
+            <a:tbl>
+              <a:tblPr>
+                <a:tableStyleId>{5C22544A-7EE6-4342-B048-85BDC9FD1C3A}</a:tableStyleId>
+              </a:tblPr>
+              <a:tblGrid>
+                <a:gridCol w="2626472"/>
+                <a:gridCol w="3939709"/>
+                <a:gridCol w="4071032"/>
+              </a:tblGrid>
+              <a:tr h="502920">
+                <a:tc>
+                  <a:txBody>
+                    <a:bodyPr wrap="square"/>
+                    <a:lstStyle/>
+                    <a:p>
+                      <a:pPr algn="l">
+                        <a:lnSpc>
+                          <a:spcPct val="100000"/>
+                        </a:lnSpc>
+                      </a:pPr>
+                      <a:r>
+                        <a:rPr sz="1600" b="1">
+                          <a:solidFill>
+                            <a:srgbClr val="FFFFFF"/>
+                          </a:solidFill>
+                          <a:latin typeface="Segoe UI Semibold"/>
+                        </a:rPr>
+                        <a:t>Component</a:t>
+                      </a:r>
+                    </a:p>
+                  </a:txBody>
+                  <a:tcPr marL="101600" marR="101600" marT="50800" marB="50800" anchor="ctr">
+                    <a:solidFill>
+                      <a:srgbClr val="1D7A8C"/>
+                    </a:solidFill>
+                  </a:tcPr>
+                </a:tc>
+                <a:tc>
+                  <a:txBody>
+                    <a:bodyPr wrap="square"/>
+                    <a:lstStyle/>
+                    <a:p>
+                      <a:pPr algn="l">
+                        <a:lnSpc>
+                          <a:spcPct val="100000"/>
+                        </a:lnSpc>
+                      </a:pPr>
+                      <a:r>
+                        <a:rPr sz="1600" b="1">
+                          <a:solidFill>
+                            <a:srgbClr val="FFFFFF"/>
+                          </a:solidFill>
+                          <a:latin typeface="Segoe UI Semibold"/>
+                        </a:rPr>
+                        <a:t>Purpose</a:t>
+                      </a:r>
+                    </a:p>
+                  </a:txBody>
+                  <a:tcPr marL="101600" marR="101600" marT="50800" marB="50800" anchor="ctr">
+                    <a:solidFill>
+                      <a:srgbClr val="1D7A8C"/>
+                    </a:solidFill>
+                  </a:tcPr>
+                </a:tc>
+                <a:tc>
+                  <a:txBody>
+                    <a:bodyPr wrap="square"/>
+                    <a:lstStyle/>
+                    <a:p>
+                      <a:pPr algn="l">
+                        <a:lnSpc>
+                          <a:spcPct val="100000"/>
+                        </a:lnSpc>
+                      </a:pPr>
+                      <a:r>
+                        <a:rPr sz="1600" b="1">
+                          <a:solidFill>
+                            <a:srgbClr val="FFFFFF"/>
+                          </a:solidFill>
+                          <a:latin typeface="Segoe UI Semibold"/>
+                        </a:rPr>
+                        <a:t>Key Question It Answers</a:t>
+                      </a:r>
+                    </a:p>
+                  </a:txBody>
+                  <a:tcPr marL="101600" marR="101600" marT="50800" marB="50800" anchor="ctr">
+                    <a:solidFill>
+                      <a:srgbClr val="1D7A8C"/>
+                    </a:solidFill>
+                  </a:tcPr>
+                </a:tc>
+              </a:tr>
+              <a:tr h="822960">
+                <a:tc>
+                  <a:txBody>
+                    <a:bodyPr wrap="square"/>
+                    <a:lstStyle/>
+                    <a:p>
+                      <a:pPr algn="l">
+                        <a:lnSpc>
+                          <a:spcPct val="100000"/>
+                        </a:lnSpc>
+                      </a:pPr>
+                      <a:r>
+                        <a:rPr sz="1500" b="0">
+                          <a:solidFill>
+                            <a:srgbClr val="14213D"/>
+                          </a:solidFill>
+                          <a:latin typeface="Segoe UI"/>
+                        </a:rPr>
+                        <a:t>Background context</a:t>
+                      </a:r>
+                    </a:p>
+                  </a:txBody>
+                  <a:tcPr marL="101600" marR="101600" marT="50800" marB="50800" anchor="ctr">
+                    <a:solidFill>
+                      <a:srgbClr val="E4F1F3"/>
+                    </a:solidFill>
+                  </a:tcPr>
+                </a:tc>
+                <a:tc>
+                  <a:txBody>
+                    <a:bodyPr wrap="square"/>
+                    <a:lstStyle/>
+                    <a:p>
+                      <a:pPr algn="l">
+                        <a:lnSpc>
+                          <a:spcPct val="100000"/>
+                        </a:lnSpc>
+                      </a:pPr>
+                      <a:r>
+                        <a:rPr sz="1500" b="0">
+                          <a:solidFill>
+                            <a:srgbClr val="14213D"/>
+                          </a:solidFill>
+                          <a:latin typeface="Segoe UI"/>
+                        </a:rPr>
+                        <a:t>Establishes the broader setting in which the problem exists</a:t>
+                      </a:r>
+                    </a:p>
+                  </a:txBody>
+                  <a:tcPr marL="101600" marR="101600" marT="50800" marB="50800" anchor="ctr">
+                    <a:solidFill>
+                      <a:srgbClr val="FFFFFF"/>
+                    </a:solidFill>
+                  </a:tcPr>
+                </a:tc>
+                <a:tc>
+                  <a:txBody>
+                    <a:bodyPr wrap="square"/>
+                    <a:lstStyle/>
+                    <a:p>
+                      <a:pPr algn="l">
+                        <a:lnSpc>
+                          <a:spcPct val="100000"/>
+                        </a:lnSpc>
+                      </a:pPr>
+                      <a:r>
+                        <a:rPr sz="1500" b="0">
+                          <a:solidFill>
+                            <a:srgbClr val="14213D"/>
+                          </a:solidFill>
+                          <a:latin typeface="Segoe UI"/>
+                        </a:rPr>
+                        <a:t>What does the reader need to know to understand why this matters?</a:t>
+                      </a:r>
+                    </a:p>
+                  </a:txBody>
+                  <a:tcPr marL="101600" marR="101600" marT="50800" marB="50800" anchor="ctr">
+                    <a:solidFill>
+                      <a:srgbClr val="FFFFFF"/>
+                    </a:solidFill>
+                  </a:tcPr>
+                </a:tc>
+              </a:tr>
+              <a:tr h="822960">
+                <a:tc>
+                  <a:txBody>
+                    <a:bodyPr wrap="square"/>
+                    <a:lstStyle/>
+                    <a:p>
+                      <a:pPr algn="l">
+                        <a:lnSpc>
+                          <a:spcPct val="100000"/>
+                        </a:lnSpc>
+                      </a:pPr>
+                      <a:r>
+                        <a:rPr sz="1500" b="0">
+                          <a:solidFill>
+                            <a:srgbClr val="14213D"/>
+                          </a:solidFill>
+                          <a:latin typeface="Segoe UI"/>
+                        </a:rPr>
+                        <a:t>Specific problem or gap</a:t>
+                      </a:r>
+                    </a:p>
+                  </a:txBody>
+                  <a:tcPr marL="101600" marR="101600" marT="50800" marB="50800" anchor="ctr">
+                    <a:solidFill>
+                      <a:srgbClr val="FCE4DD"/>
+                    </a:solidFill>
+                  </a:tcPr>
+                </a:tc>
+                <a:tc>
+                  <a:txBody>
+                    <a:bodyPr wrap="square"/>
+                    <a:lstStyle/>
+                    <a:p>
+                      <a:pPr algn="l">
+                        <a:lnSpc>
+                          <a:spcPct val="100000"/>
+                        </a:lnSpc>
+                      </a:pPr>
+                      <a:r>
+                        <a:rPr sz="1500" b="0">
+                          <a:solidFill>
+                            <a:srgbClr val="14213D"/>
+                          </a:solidFill>
+                          <a:latin typeface="Segoe UI"/>
+                        </a:rPr>
+                        <a:t>Names the precise issue, contradiction, or knowledge gap the study addresses</a:t>
+                      </a:r>
+                    </a:p>
+                  </a:txBody>
+                  <a:tcPr marL="101600" marR="101600" marT="50800" marB="50800" anchor="ctr">
+                    <a:solidFill>
+                      <a:srgbClr val="EEF4F7"/>
+                    </a:solidFill>
+                  </a:tcPr>
+                </a:tc>
+                <a:tc>
+                  <a:txBody>
+                    <a:bodyPr wrap="square"/>
+                    <a:lstStyle/>
+                    <a:p>
+                      <a:pPr algn="l">
+                        <a:lnSpc>
+                          <a:spcPct val="100000"/>
+                        </a:lnSpc>
+                      </a:pPr>
+                      <a:r>
+                        <a:rPr sz="1500" b="0">
+                          <a:solidFill>
+                            <a:srgbClr val="14213D"/>
+                          </a:solidFill>
+                          <a:latin typeface="Segoe UI"/>
+                        </a:rPr>
+                        <a:t>What exactly is wrong, missing, or unresolved?</a:t>
+                      </a:r>
+                    </a:p>
+                  </a:txBody>
+                  <a:tcPr marL="101600" marR="101600" marT="50800" marB="50800" anchor="ctr">
+                    <a:solidFill>
+                      <a:srgbClr val="EEF4F7"/>
+                    </a:solidFill>
+                  </a:tcPr>
+                </a:tc>
+              </a:tr>
+              <a:tr h="822960">
+                <a:tc>
+                  <a:txBody>
+                    <a:bodyPr wrap="square"/>
+                    <a:lstStyle/>
+                    <a:p>
+                      <a:pPr algn="l">
+                        <a:lnSpc>
+                          <a:spcPct val="100000"/>
+                        </a:lnSpc>
+                      </a:pPr>
+                      <a:r>
+                        <a:rPr sz="1500" b="0">
+                          <a:solidFill>
+                            <a:srgbClr val="14213D"/>
+                          </a:solidFill>
+                          <a:latin typeface="Segoe UI"/>
+                        </a:rPr>
+                        <a:t>Implications</a:t>
+                      </a:r>
+                    </a:p>
+                  </a:txBody>
+                  <a:tcPr marL="101600" marR="101600" marT="50800" marB="50800" anchor="ctr">
+                    <a:solidFill>
+                      <a:srgbClr val="FCF0CC"/>
+                    </a:solidFill>
+                  </a:tcPr>
+                </a:tc>
+                <a:tc>
+                  <a:txBody>
+                    <a:bodyPr wrap="square"/>
+                    <a:lstStyle/>
+                    <a:p>
+                      <a:pPr algn="l">
+                        <a:lnSpc>
+                          <a:spcPct val="100000"/>
+                        </a:lnSpc>
+                      </a:pPr>
+                      <a:r>
+                        <a:rPr sz="1500" b="0">
+                          <a:solidFill>
+                            <a:srgbClr val="14213D"/>
+                          </a:solidFill>
+                          <a:latin typeface="Segoe UI"/>
+                        </a:rPr>
+                        <a:t>Explains the consequences of leaving the problem unresolved</a:t>
+                      </a:r>
+                    </a:p>
+                  </a:txBody>
+                  <a:tcPr marL="101600" marR="101600" marT="50800" marB="50800" anchor="ctr">
+                    <a:solidFill>
+                      <a:srgbClr val="FFFFFF"/>
+                    </a:solidFill>
+                  </a:tcPr>
+                </a:tc>
+                <a:tc>
+                  <a:txBody>
+                    <a:bodyPr wrap="square"/>
+                    <a:lstStyle/>
+                    <a:p>
+                      <a:pPr algn="l">
+                        <a:lnSpc>
+                          <a:spcPct val="100000"/>
+                        </a:lnSpc>
+                      </a:pPr>
+                      <a:r>
+                        <a:rPr sz="1500" b="0">
+                          <a:solidFill>
+                            <a:srgbClr val="14213D"/>
+                          </a:solidFill>
+                          <a:latin typeface="Segoe UI"/>
+                        </a:rPr>
+                        <a:t>Who is affected, and what are the costs of inaction?</a:t>
+                      </a:r>
+                    </a:p>
+                  </a:txBody>
+                  <a:tcPr marL="101600" marR="101600" marT="50800" marB="50800" anchor="ctr">
+                    <a:solidFill>
+                      <a:srgbClr val="FFFFFF"/>
+                    </a:solidFill>
+                  </a:tcPr>
+                </a:tc>
+              </a:tr>
+              <a:tr h="822960">
+                <a:tc>
+                  <a:txBody>
+                    <a:bodyPr wrap="square"/>
+                    <a:lstStyle/>
+                    <a:p>
+                      <a:pPr algn="l">
+                        <a:lnSpc>
+                          <a:spcPct val="100000"/>
+                        </a:lnSpc>
+                      </a:pPr>
+                      <a:r>
+                        <a:rPr sz="1500" b="0">
+                          <a:solidFill>
+                            <a:srgbClr val="14213D"/>
+                          </a:solidFill>
+                          <a:latin typeface="Segoe UI"/>
+                        </a:rPr>
+                        <a:t>Objectives or aims</a:t>
+                      </a:r>
+                    </a:p>
+                  </a:txBody>
+                  <a:tcPr marL="101600" marR="101600" marT="50800" marB="50800" anchor="ctr">
+                    <a:solidFill>
+                      <a:srgbClr val="D9F0EC"/>
+                    </a:solidFill>
+                  </a:tcPr>
+                </a:tc>
+                <a:tc>
+                  <a:txBody>
+                    <a:bodyPr wrap="square"/>
+                    <a:lstStyle/>
+                    <a:p>
+                      <a:pPr algn="l">
+                        <a:lnSpc>
+                          <a:spcPct val="100000"/>
+                        </a:lnSpc>
+                      </a:pPr>
+                      <a:r>
+                        <a:rPr sz="1500" b="0">
+                          <a:solidFill>
+                            <a:srgbClr val="14213D"/>
+                          </a:solidFill>
+                          <a:latin typeface="Segoe UI"/>
+                        </a:rPr>
+                        <a:t>States what the study will do in response to the gap</a:t>
+                      </a:r>
+                    </a:p>
+                  </a:txBody>
+                  <a:tcPr marL="101600" marR="101600" marT="50800" marB="50800" anchor="ctr">
+                    <a:solidFill>
+                      <a:srgbClr val="EEF4F7"/>
+                    </a:solidFill>
+                  </a:tcPr>
+                </a:tc>
+                <a:tc>
+                  <a:txBody>
+                    <a:bodyPr wrap="square"/>
+                    <a:lstStyle/>
+                    <a:p>
+                      <a:pPr algn="l">
+                        <a:lnSpc>
+                          <a:spcPct val="100000"/>
+                        </a:lnSpc>
+                      </a:pPr>
+                      <a:r>
+                        <a:rPr sz="1500" b="0">
+                          <a:solidFill>
+                            <a:srgbClr val="14213D"/>
+                          </a:solidFill>
+                          <a:latin typeface="Segoe UI"/>
+                        </a:rPr>
+                        <a:t>What will this research investigate or accomplish?</a:t>
+                      </a:r>
+                    </a:p>
+                  </a:txBody>
+                  <a:tcPr marL="101600" marR="101600" marT="50800" marB="50800" anchor="ctr">
+                    <a:solidFill>
+                      <a:srgbClr val="EEF4F7"/>
+                    </a:solidFill>
+                  </a:tcPr>
+                </a:tc>
+              </a:tr>
+            </a:tbl>
+          </a:graphicData>
+        </a:graphic>
+      </p:graphicFrame>
     </p:spTree>
   </p:cSld>
   <p:clrMapOvr>
@@ -21277,13 +21474,13 @@
               </a:spcAft>
             </a:pPr>
             <a:r>
-              <a:rPr sz="2500" b="1" i="0">
+              <a:rPr sz="2700" b="1" i="0">
                 <a:solidFill>
                   <a:srgbClr val="14213D"/>
                 </a:solidFill>
                 <a:latin typeface="Segoe UI Semibold"/>
               </a:rPr>
-              <a:t>Example — Writing a Problem Statement Step by Step</a:t>
+              <a:t>Example — One Sentence per Component</a:t>
             </a:r>
           </a:p>
         </p:txBody>
@@ -21539,318 +21736,20 @@
         <p:spPr>
           <a:xfrm>
             <a:off x="777240" y="2194560"/>
-            <a:ext cx="109728" cy="621792"/>
+            <a:ext cx="5090007" cy="3950208"/>
           </a:xfrm>
           <a:prstGeom prst="roundRect">
             <a:avLst>
-              <a:gd name="adj" fmla="val 50000"/>
+              <a:gd name="adj" fmla="val 6000"/>
             </a:avLst>
           </a:prstGeom>
           <a:solidFill>
-            <a:srgbClr val="1D7A8C"/>
+            <a:srgbClr val="FFFFFF"/>
           </a:solidFill>
-          <a:ln>
-            <a:noFill/>
-          </a:ln>
-          <a:effectLst/>
-        </p:spPr>
-        <p:style>
-          <a:lnRef idx="1">
-            <a:schemeClr val="accent1"/>
-          </a:lnRef>
-          <a:fillRef idx="3">
-            <a:schemeClr val="accent1"/>
-          </a:fillRef>
-          <a:effectRef idx="2">
-            <a:schemeClr val="accent1"/>
-          </a:effectRef>
-          <a:fontRef idx="minor">
-            <a:schemeClr val="lt1"/>
-          </a:fontRef>
-        </p:style>
-        <p:txBody>
-          <a:bodyPr rtlCol="0" anchor="ctr" wrap="square"/>
-          <a:lstStyle/>
-          <a:p>
-            <a:pPr algn="ctr"/>
-          </a:p>
-        </p:txBody>
-      </p:sp>
-      <p:sp>
-        <p:nvSpPr>
-          <p:cNvPr id="12" name="TextBox 11"/>
-          <p:cNvSpPr txBox="1"/>
-          <p:nvPr/>
-        </p:nvSpPr>
-        <p:spPr>
-          <a:xfrm>
-            <a:off x="1051560" y="2194560"/>
-            <a:ext cx="10271455" cy="685800"/>
-          </a:xfrm>
-          <a:prstGeom prst="rect">
-            <a:avLst/>
-          </a:prstGeom>
-          <a:noFill/>
-        </p:spPr>
-        <p:txBody>
-          <a:bodyPr wrap="square" anchor="ctr" lIns="0" rIns="0" tIns="0" bIns="0">
-            <a:spAutoFit/>
-          </a:bodyPr>
-          <a:lstStyle/>
-          <a:p>
-            <a:pPr algn="l">
-              <a:lnSpc>
-                <a:spcPct val="105000"/>
-              </a:lnSpc>
-              <a:spcBef>
-                <a:spcPts val="0"/>
-              </a:spcBef>
-              <a:spcAft>
-                <a:spcPts val="0"/>
-              </a:spcAft>
-            </a:pPr>
-            <a:r>
-              <a:rPr sz="1800" b="1" i="0">
-                <a:solidFill>
-                  <a:srgbClr val="1D7A8C"/>
-                </a:solidFill>
-                <a:latin typeface="Segoe UI Semibold"/>
-              </a:rPr>
-              <a:t>Context:  </a:t>
-            </a:r>
-            <a:r>
-              <a:rPr sz="1800" b="0" i="0">
-                <a:solidFill>
-                  <a:srgbClr val="14213D"/>
-                </a:solidFill>
-                <a:latin typeface="Segoe UI"/>
-              </a:rPr>
-              <a:t>Many coastal barangays rely on unsafe drinking water sources, and low-cost solar distillers have been proposed as a solution</a:t>
-            </a:r>
-          </a:p>
-        </p:txBody>
-      </p:sp>
-      <p:sp>
-        <p:nvSpPr>
-          <p:cNvPr id="13" name="Rounded Rectangle 12"/>
-          <p:cNvSpPr/>
-          <p:nvPr/>
-        </p:nvSpPr>
-        <p:spPr>
-          <a:xfrm>
-            <a:off x="777240" y="2907791"/>
-            <a:ext cx="109728" cy="621792"/>
-          </a:xfrm>
-          <a:prstGeom prst="roundRect">
-            <a:avLst>
-              <a:gd name="adj" fmla="val 50000"/>
-            </a:avLst>
-          </a:prstGeom>
-          <a:solidFill>
-            <a:srgbClr val="F4795B"/>
-          </a:solidFill>
-          <a:ln>
-            <a:noFill/>
-          </a:ln>
-          <a:effectLst/>
-        </p:spPr>
-        <p:style>
-          <a:lnRef idx="1">
-            <a:schemeClr val="accent1"/>
-          </a:lnRef>
-          <a:fillRef idx="3">
-            <a:schemeClr val="accent1"/>
-          </a:fillRef>
-          <a:effectRef idx="2">
-            <a:schemeClr val="accent1"/>
-          </a:effectRef>
-          <a:fontRef idx="minor">
-            <a:schemeClr val="lt1"/>
-          </a:fontRef>
-        </p:style>
-        <p:txBody>
-          <a:bodyPr rtlCol="0" anchor="ctr" wrap="square"/>
-          <a:lstStyle/>
-          <a:p>
-            <a:pPr algn="ctr"/>
-          </a:p>
-        </p:txBody>
-      </p:sp>
-      <p:sp>
-        <p:nvSpPr>
-          <p:cNvPr id="14" name="TextBox 13"/>
-          <p:cNvSpPr txBox="1"/>
-          <p:nvPr/>
-        </p:nvSpPr>
-        <p:spPr>
-          <a:xfrm>
-            <a:off x="1051560" y="2907791"/>
-            <a:ext cx="10271455" cy="685800"/>
-          </a:xfrm>
-          <a:prstGeom prst="rect">
-            <a:avLst/>
-          </a:prstGeom>
-          <a:noFill/>
-        </p:spPr>
-        <p:txBody>
-          <a:bodyPr wrap="square" anchor="ctr" lIns="0" rIns="0" tIns="0" bIns="0">
-            <a:spAutoFit/>
-          </a:bodyPr>
-          <a:lstStyle/>
-          <a:p>
-            <a:pPr algn="l">
-              <a:lnSpc>
-                <a:spcPct val="105000"/>
-              </a:lnSpc>
-              <a:spcBef>
-                <a:spcPts val="0"/>
-              </a:spcBef>
-              <a:spcAft>
-                <a:spcPts val="0"/>
-              </a:spcAft>
-            </a:pPr>
-            <a:r>
-              <a:rPr sz="1800" b="1" i="0">
-                <a:solidFill>
-                  <a:srgbClr val="F4795B"/>
-                </a:solidFill>
-                <a:latin typeface="Segoe UI Semibold"/>
-              </a:rPr>
-              <a:t>Relevance:  </a:t>
-            </a:r>
-            <a:r>
-              <a:rPr sz="1800" b="0" i="0">
-                <a:solidFill>
-                  <a:srgbClr val="14213D"/>
-                </a:solidFill>
-                <a:latin typeface="Segoe UI"/>
-              </a:rPr>
-              <a:t>Existing studies test either distiller efficiency or water safety standards, but rarely both together in an actual barangay setting</a:t>
-            </a:r>
-          </a:p>
-        </p:txBody>
-      </p:sp>
-      <p:sp>
-        <p:nvSpPr>
-          <p:cNvPr id="15" name="Rounded Rectangle 14"/>
-          <p:cNvSpPr/>
-          <p:nvPr/>
-        </p:nvSpPr>
-        <p:spPr>
-          <a:xfrm>
-            <a:off x="777240" y="3621024"/>
-            <a:ext cx="109728" cy="621792"/>
-          </a:xfrm>
-          <a:prstGeom prst="roundRect">
-            <a:avLst>
-              <a:gd name="adj" fmla="val 50000"/>
-            </a:avLst>
-          </a:prstGeom>
-          <a:solidFill>
-            <a:srgbClr val="2A9D8F"/>
-          </a:solidFill>
-          <a:ln>
-            <a:noFill/>
-          </a:ln>
-          <a:effectLst/>
-        </p:spPr>
-        <p:style>
-          <a:lnRef idx="1">
-            <a:schemeClr val="accent1"/>
-          </a:lnRef>
-          <a:fillRef idx="3">
-            <a:schemeClr val="accent1"/>
-          </a:fillRef>
-          <a:effectRef idx="2">
-            <a:schemeClr val="accent1"/>
-          </a:effectRef>
-          <a:fontRef idx="minor">
-            <a:schemeClr val="lt1"/>
-          </a:fontRef>
-        </p:style>
-        <p:txBody>
-          <a:bodyPr rtlCol="0" anchor="ctr" wrap="square"/>
-          <a:lstStyle/>
-          <a:p>
-            <a:pPr algn="ctr"/>
-          </a:p>
-        </p:txBody>
-      </p:sp>
-      <p:sp>
-        <p:nvSpPr>
-          <p:cNvPr id="16" name="TextBox 15"/>
-          <p:cNvSpPr txBox="1"/>
-          <p:nvPr/>
-        </p:nvSpPr>
-        <p:spPr>
-          <a:xfrm>
-            <a:off x="1051560" y="3621024"/>
-            <a:ext cx="10271455" cy="685800"/>
-          </a:xfrm>
-          <a:prstGeom prst="rect">
-            <a:avLst/>
-          </a:prstGeom>
-          <a:noFill/>
-        </p:spPr>
-        <p:txBody>
-          <a:bodyPr wrap="square" anchor="ctr" lIns="0" rIns="0" tIns="0" bIns="0">
-            <a:spAutoFit/>
-          </a:bodyPr>
-          <a:lstStyle/>
-          <a:p>
-            <a:pPr algn="l">
-              <a:lnSpc>
-                <a:spcPct val="105000"/>
-              </a:lnSpc>
-              <a:spcBef>
-                <a:spcPts val="0"/>
-              </a:spcBef>
-              <a:spcAft>
-                <a:spcPts val="0"/>
-              </a:spcAft>
-            </a:pPr>
-            <a:r>
-              <a:rPr sz="1800" b="1" i="0">
-                <a:solidFill>
-                  <a:srgbClr val="2A9D8F"/>
-                </a:solidFill>
-                <a:latin typeface="Segoe UI Semibold"/>
-              </a:rPr>
-              <a:t>Strategy:  </a:t>
-            </a:r>
-            <a:r>
-              <a:rPr sz="1800" b="0" i="0">
-                <a:solidFill>
-                  <a:srgbClr val="14213D"/>
-                </a:solidFill>
-                <a:latin typeface="Segoe UI"/>
-              </a:rPr>
-              <a:t>This study will test the distiller's real-world effect on microbial water safety</a:t>
-            </a:r>
-          </a:p>
-        </p:txBody>
-      </p:sp>
-      <p:sp>
-        <p:nvSpPr>
-          <p:cNvPr id="17" name="Rounded Rectangle 16"/>
-          <p:cNvSpPr/>
-          <p:nvPr/>
-        </p:nvSpPr>
-        <p:spPr>
-          <a:xfrm>
-            <a:off x="777240" y="4379976"/>
-            <a:ext cx="10637215" cy="1051560"/>
-          </a:xfrm>
-          <a:prstGeom prst="roundRect">
-            <a:avLst>
-              <a:gd name="adj" fmla="val 8000"/>
-            </a:avLst>
-          </a:prstGeom>
-          <a:solidFill>
-            <a:srgbClr val="14213D"/>
-          </a:solidFill>
-          <a:ln>
-            <a:noFill/>
+          <a:ln w="12700">
+            <a:solidFill>
+              <a:srgbClr val="D8E1E8"/>
+            </a:solidFill>
           </a:ln>
           <a:effectLst>
             <a:outerShdw blurRad="127000" dist="63500" dir="5400000" rotWithShape="0">
@@ -21884,14 +21783,60 @@
       </p:sp>
       <p:sp>
         <p:nvSpPr>
-          <p:cNvPr id="18" name="TextBox 17"/>
+          <p:cNvPr id="12" name="Rounded Rectangle 11"/>
+          <p:cNvSpPr/>
+          <p:nvPr/>
+        </p:nvSpPr>
+        <p:spPr>
+          <a:xfrm>
+            <a:off x="777240" y="2194560"/>
+            <a:ext cx="5090007" cy="566928"/>
+          </a:xfrm>
+          <a:prstGeom prst="roundRect">
+            <a:avLst>
+              <a:gd name="adj" fmla="val 12000"/>
+            </a:avLst>
+          </a:prstGeom>
+          <a:solidFill>
+            <a:srgbClr val="14213D"/>
+          </a:solidFill>
+          <a:ln>
+            <a:noFill/>
+          </a:ln>
+          <a:effectLst/>
+        </p:spPr>
+        <p:style>
+          <a:lnRef idx="1">
+            <a:schemeClr val="accent1"/>
+          </a:lnRef>
+          <a:fillRef idx="3">
+            <a:schemeClr val="accent1"/>
+          </a:fillRef>
+          <a:effectRef idx="2">
+            <a:schemeClr val="accent1"/>
+          </a:effectRef>
+          <a:fontRef idx="minor">
+            <a:schemeClr val="lt1"/>
+          </a:fontRef>
+        </p:style>
+        <p:txBody>
+          <a:bodyPr rtlCol="0" anchor="ctr" wrap="square"/>
+          <a:lstStyle/>
+          <a:p>
+            <a:pPr algn="ctr"/>
+          </a:p>
+        </p:txBody>
+      </p:sp>
+      <p:sp>
+        <p:nvSpPr>
+          <p:cNvPr id="13" name="TextBox 12"/>
           <p:cNvSpPr txBox="1"/>
           <p:nvPr/>
         </p:nvSpPr>
         <p:spPr>
           <a:xfrm>
-            <a:off x="1097280" y="4379976"/>
-            <a:ext cx="9997135" cy="1051560"/>
+            <a:off x="1033271" y="2194560"/>
+            <a:ext cx="4651095" cy="566928"/>
           </a:xfrm>
           <a:prstGeom prst="rect">
             <a:avLst/>
@@ -21912,39 +21857,376 @@
                 <a:spcPts val="0"/>
               </a:spcBef>
               <a:spcAft>
-                <a:spcPts val="300"/>
+                <a:spcPts val="0"/>
               </a:spcAft>
             </a:pPr>
             <a:r>
-              <a:rPr sz="1300" b="1" i="0">
-                <a:solidFill>
-                  <a:srgbClr val="F2B705"/>
+              <a:rPr sz="1450" b="1" i="0">
+                <a:solidFill>
+                  <a:srgbClr val="FFFFFF"/>
                 </a:solidFill>
                 <a:latin typeface="Segoe UI Semibold"/>
               </a:rPr>
-              <a:t>FINAL PROBLEM STATEMENT</a:t>
-            </a:r>
-          </a:p>
+              <a:t>BUILD: ONE SENTENCE PER COMPONENT</a:t>
+            </a:r>
+          </a:p>
+        </p:txBody>
+      </p:sp>
+      <p:sp>
+        <p:nvSpPr>
+          <p:cNvPr id="14" name="TextBox 13"/>
+          <p:cNvSpPr txBox="1"/>
+          <p:nvPr/>
+        </p:nvSpPr>
+        <p:spPr>
+          <a:xfrm>
+            <a:off x="1033271" y="2852928"/>
+            <a:ext cx="4577943" cy="3172968"/>
+          </a:xfrm>
+          <a:prstGeom prst="rect">
+            <a:avLst/>
+          </a:prstGeom>
+          <a:noFill/>
+        </p:spPr>
+        <p:txBody>
+          <a:bodyPr wrap="square" anchor="t" lIns="0" rIns="0" tIns="0" bIns="0">
+            <a:spAutoFit/>
+          </a:bodyPr>
+          <a:lstStyle/>
           <a:p>
             <a:pPr algn="l">
               <a:lnSpc>
-                <a:spcPct val="108000"/>
+                <a:spcPct val="103000"/>
               </a:lnSpc>
               <a:spcBef>
                 <a:spcPts val="0"/>
               </a:spcBef>
               <a:spcAft>
-                <a:spcPts val="0"/>
+                <a:spcPts val="500"/>
               </a:spcAft>
             </a:pPr>
             <a:r>
-              <a:rPr sz="1750" b="0" i="1">
+              <a:rPr sz="1300" b="1" i="0">
+                <a:solidFill>
+                  <a:srgbClr val="1D7A8C"/>
+                </a:solidFill>
+                <a:latin typeface="Segoe UI Semibold"/>
+              </a:rPr>
+              <a:t>Background context: </a:t>
+            </a:r>
+            <a:r>
+              <a:rPr sz="1300" b="0" i="0">
+                <a:solidFill>
+                  <a:srgbClr val="14213D"/>
+                </a:solidFill>
+                <a:latin typeface="Segoe UI"/>
+              </a:rPr>
+              <a:t>Many coastal barangays in the Philippines depend on shallow wells and rainwater catchments that are vulnerable to microbial contamination, and low-cost solar water distillers have been promoted as an accessible treatment option.</a:t>
+            </a:r>
+          </a:p>
+          <a:p>
+            <a:pPr algn="l">
+              <a:lnSpc>
+                <a:spcPct val="103000"/>
+              </a:lnSpc>
+              <a:spcBef>
+                <a:spcPts val="0"/>
+              </a:spcBef>
+              <a:spcAft>
+                <a:spcPts val="500"/>
+              </a:spcAft>
+            </a:pPr>
+            <a:r>
+              <a:rPr sz="1300" b="1" i="0">
+                <a:solidFill>
+                  <a:srgbClr val="F4795B"/>
+                </a:solidFill>
+                <a:latin typeface="Segoe UI Semibold"/>
+              </a:rPr>
+              <a:t>Specific problem or gap: </a:t>
+            </a:r>
+            <a:r>
+              <a:rPr sz="1300" b="0" i="0">
+                <a:solidFill>
+                  <a:srgbClr val="14213D"/>
+                </a:solidFill>
+                <a:latin typeface="Segoe UI"/>
+              </a:rPr>
+              <a:t>However, existing studies evaluate either the distiller's efficiency or general water safety standards separately, with very few directly measuring the distiller's actual effect on microbial contamination in a real barangay setting.</a:t>
+            </a:r>
+          </a:p>
+          <a:p>
+            <a:pPr algn="l">
+              <a:lnSpc>
+                <a:spcPct val="103000"/>
+              </a:lnSpc>
+              <a:spcBef>
+                <a:spcPts val="0"/>
+              </a:spcBef>
+              <a:spcAft>
+                <a:spcPts val="500"/>
+              </a:spcAft>
+            </a:pPr>
+            <a:r>
+              <a:rPr sz="1300" b="1" i="0">
+                <a:solidFill>
+                  <a:srgbClr val="C0870A"/>
+                </a:solidFill>
+                <a:latin typeface="Segoe UI Semibold"/>
+              </a:rPr>
+              <a:t>Implications: </a:t>
+            </a:r>
+            <a:r>
+              <a:rPr sz="1300" b="0" i="0">
+                <a:solidFill>
+                  <a:srgbClr val="14213D"/>
+                </a:solidFill>
+                <a:latin typeface="Segoe UI"/>
+              </a:rPr>
+              <a:t>Without this evidence, communities and local health workers risk relying on a technology whose real protective effect on drinking water safety remains unverified, which could expose residents to preventable waterborne illness.</a:t>
+            </a:r>
+          </a:p>
+          <a:p>
+            <a:pPr algn="l">
+              <a:lnSpc>
+                <a:spcPct val="103000"/>
+              </a:lnSpc>
+              <a:spcBef>
+                <a:spcPts val="0"/>
+              </a:spcBef>
+              <a:spcAft>
+                <a:spcPts val="500"/>
+              </a:spcAft>
+            </a:pPr>
+            <a:r>
+              <a:rPr sz="1300" b="1" i="0">
+                <a:solidFill>
+                  <a:srgbClr val="2A9D8F"/>
+                </a:solidFill>
+                <a:latin typeface="Segoe UI Semibold"/>
+              </a:rPr>
+              <a:t>Objectives or aims: </a:t>
+            </a:r>
+            <a:r>
+              <a:rPr sz="1300" b="0" i="0">
+                <a:solidFill>
+                  <a:srgbClr val="14213D"/>
+                </a:solidFill>
+                <a:latin typeface="Segoe UI"/>
+              </a:rPr>
+              <a:t>This study, therefore, aims to determine the effect of a low-cost solar water distiller on the microbial safety of drinking water in a coastal barangay in Zambales.</a:t>
+            </a:r>
+          </a:p>
+        </p:txBody>
+      </p:sp>
+      <p:sp>
+        <p:nvSpPr>
+          <p:cNvPr id="15" name="Rounded Rectangle 14"/>
+          <p:cNvSpPr/>
+          <p:nvPr/>
+        </p:nvSpPr>
+        <p:spPr>
+          <a:xfrm>
+            <a:off x="6324447" y="2194560"/>
+            <a:ext cx="5090007" cy="3950208"/>
+          </a:xfrm>
+          <a:prstGeom prst="roundRect">
+            <a:avLst>
+              <a:gd name="adj" fmla="val 6000"/>
+            </a:avLst>
+          </a:prstGeom>
+          <a:solidFill>
+            <a:srgbClr val="FBFDFE"/>
+          </a:solidFill>
+          <a:ln w="12700">
+            <a:solidFill>
+              <a:srgbClr val="2A9D8F"/>
+            </a:solidFill>
+          </a:ln>
+          <a:effectLst>
+            <a:outerShdw blurRad="127000" dist="63500" dir="5400000" rotWithShape="0">
+              <a:srgbClr val="1B2A3A">
+                <a:alpha val="24000"/>
+              </a:srgbClr>
+            </a:outerShdw>
+          </a:effectLst>
+        </p:spPr>
+        <p:style>
+          <a:lnRef idx="1">
+            <a:schemeClr val="accent1"/>
+          </a:lnRef>
+          <a:fillRef idx="3">
+            <a:schemeClr val="accent1"/>
+          </a:fillRef>
+          <a:effectRef idx="2">
+            <a:schemeClr val="accent1"/>
+          </a:effectRef>
+          <a:fontRef idx="minor">
+            <a:schemeClr val="lt1"/>
+          </a:fontRef>
+        </p:style>
+        <p:txBody>
+          <a:bodyPr rtlCol="0" anchor="ctr" wrap="square"/>
+          <a:lstStyle/>
+          <a:p>
+            <a:pPr algn="ctr"/>
+          </a:p>
+        </p:txBody>
+      </p:sp>
+      <p:sp>
+        <p:nvSpPr>
+          <p:cNvPr id="16" name="Rounded Rectangle 15"/>
+          <p:cNvSpPr/>
+          <p:nvPr/>
+        </p:nvSpPr>
+        <p:spPr>
+          <a:xfrm>
+            <a:off x="6324447" y="2194560"/>
+            <a:ext cx="5090007" cy="566928"/>
+          </a:xfrm>
+          <a:prstGeom prst="roundRect">
+            <a:avLst>
+              <a:gd name="adj" fmla="val 12000"/>
+            </a:avLst>
+          </a:prstGeom>
+          <a:solidFill>
+            <a:srgbClr val="2A9D8F"/>
+          </a:solidFill>
+          <a:ln>
+            <a:noFill/>
+          </a:ln>
+          <a:effectLst/>
+        </p:spPr>
+        <p:style>
+          <a:lnRef idx="1">
+            <a:schemeClr val="accent1"/>
+          </a:lnRef>
+          <a:fillRef idx="3">
+            <a:schemeClr val="accent1"/>
+          </a:fillRef>
+          <a:effectRef idx="2">
+            <a:schemeClr val="accent1"/>
+          </a:effectRef>
+          <a:fontRef idx="minor">
+            <a:schemeClr val="lt1"/>
+          </a:fontRef>
+        </p:style>
+        <p:txBody>
+          <a:bodyPr rtlCol="0" anchor="ctr" wrap="square"/>
+          <a:lstStyle/>
+          <a:p>
+            <a:pPr algn="ctr"/>
+          </a:p>
+        </p:txBody>
+      </p:sp>
+      <p:sp>
+        <p:nvSpPr>
+          <p:cNvPr id="17" name="TextBox 16"/>
+          <p:cNvSpPr txBox="1"/>
+          <p:nvPr/>
+        </p:nvSpPr>
+        <p:spPr>
+          <a:xfrm>
+            <a:off x="6580479" y="2194560"/>
+            <a:ext cx="4651095" cy="566928"/>
+          </a:xfrm>
+          <a:prstGeom prst="rect">
+            <a:avLst/>
+          </a:prstGeom>
+          <a:noFill/>
+        </p:spPr>
+        <p:txBody>
+          <a:bodyPr wrap="square" anchor="ctr" lIns="0" rIns="0" tIns="0" bIns="0">
+            <a:spAutoFit/>
+          </a:bodyPr>
+          <a:lstStyle/>
+          <a:p>
+            <a:pPr algn="l">
+              <a:lnSpc>
+                <a:spcPct val="105000"/>
+              </a:lnSpc>
+              <a:spcBef>
+                <a:spcPts val="0"/>
+              </a:spcBef>
+              <a:spcAft>
+                <a:spcPts val="0"/>
+              </a:spcAft>
+            </a:pPr>
+            <a:r>
+              <a:rPr sz="1450" b="1" i="0">
                 <a:solidFill>
                   <a:srgbClr val="FFFFFF"/>
                 </a:solidFill>
+                <a:latin typeface="Segoe UI Semibold"/>
+              </a:rPr>
+              <a:t>FINISHED PROBLEM STATEMENT</a:t>
+            </a:r>
+          </a:p>
+        </p:txBody>
+      </p:sp>
+      <p:sp>
+        <p:nvSpPr>
+          <p:cNvPr id="18" name="TextBox 17"/>
+          <p:cNvSpPr txBox="1"/>
+          <p:nvPr/>
+        </p:nvSpPr>
+        <p:spPr>
+          <a:xfrm>
+            <a:off x="6580479" y="2852928"/>
+            <a:ext cx="4577943" cy="3172968"/>
+          </a:xfrm>
+          <a:prstGeom prst="rect">
+            <a:avLst/>
+          </a:prstGeom>
+          <a:noFill/>
+        </p:spPr>
+        <p:txBody>
+          <a:bodyPr wrap="square" anchor="t" lIns="0" rIns="0" tIns="0" bIns="0">
+            <a:spAutoFit/>
+          </a:bodyPr>
+          <a:lstStyle/>
+          <a:p>
+            <a:pPr algn="l">
+              <a:lnSpc>
+                <a:spcPct val="116000"/>
+              </a:lnSpc>
+              <a:spcBef>
+                <a:spcPts val="0"/>
+              </a:spcBef>
+              <a:spcAft>
+                <a:spcPts val="600"/>
+              </a:spcAft>
+            </a:pPr>
+            <a:r>
+              <a:rPr sz="1300" b="0" i="1">
+                <a:solidFill>
+                  <a:srgbClr val="14213D"/>
+                </a:solidFill>
                 <a:latin typeface="Segoe UI"/>
               </a:rPr>
-              <a:t>“This study addresses the limited evidence on whether a low-cost solar water distiller measurably improves the microbial safety of drinking water in a coastal barangay setting.”</a:t>
+              <a:t>“Many coastal barangays in the Philippines depend on shallow wells and rainwater catchments that are vulnerable to microbial contamination, and low-cost solar water distillers have been promoted as an accessible treatment option. However, existing studies evaluate either the distiller's efficiency or general water safety standards separately, with very few directly measuring the distiller's actual effect on microbial contamination in a real barangay setting. Without this evidence, communities and local health workers risk relying on a technology whose real protective effect on drinking water safety remains unverified, which could expose residents to preventable waterborne illness. This study, therefore, aims to determine the effect of a low-cost solar water distiller on the microbial safety of drinking water in a coastal barangay in Zambales.”</a:t>
+            </a:r>
+          </a:p>
+          <a:p>
+            <a:pPr algn="l">
+              <a:lnSpc>
+                <a:spcPct val="100000"/>
+              </a:lnSpc>
+              <a:spcBef>
+                <a:spcPts val="0"/>
+              </a:spcBef>
+              <a:spcAft>
+                <a:spcPts val="0"/>
+              </a:spcAft>
+            </a:pPr>
+            <a:r>
+              <a:rPr sz="1150" b="0" i="1">
+                <a:solidFill>
+                  <a:srgbClr val="5B6B7B"/>
+                </a:solidFill>
+                <a:latin typeface="Segoe UI"/>
+              </a:rPr>
+              <a:t>The four components read as one natural paragraph — a drafting scaffold, not labeled boxes.</a:t>
             </a:r>
           </a:p>
         </p:txBody>
@@ -22308,7 +22590,7 @@
         </p:nvGraphicFramePr>
         <p:xfrm>
           <a:off x="777240" y="1965960"/>
-          <a:ext cx="10637214" cy="3675888"/>
+          <a:ext cx="10637214" cy="3822192"/>
         </p:xfrm>
         <a:graphic>
           <a:graphicData uri="http://schemas.openxmlformats.org/drawingml/2006/table">
@@ -22317,8 +22599,9 @@
                 <a:tableStyleId>{5C22544A-7EE6-4342-B048-85BDC9FD1C3A}</a:tableStyleId>
               </a:tblPr>
               <a:tblGrid>
-                <a:gridCol w="5689673"/>
-                <a:gridCol w="4947541"/>
+                <a:gridCol w="3934312"/>
+                <a:gridCol w="2768590"/>
+                <a:gridCol w="3934312"/>
               </a:tblGrid>
               <a:tr h="530352">
                 <a:tc>
@@ -22332,7 +22615,7 @@
                         </a:lnSpc>
                       </a:pPr>
                       <a:r>
-                        <a:rPr sz="1800" b="1">
+                        <a:rPr sz="1700" b="1">
                           <a:solidFill>
                             <a:srgbClr val="FFFFFF"/>
                           </a:solidFill>
@@ -22359,7 +22642,34 @@
                         </a:lnSpc>
                       </a:pPr>
                       <a:r>
-                        <a:rPr sz="1800" b="1">
+                        <a:rPr sz="1700" b="1">
+                          <a:solidFill>
+                            <a:srgbClr val="FFFFFF"/>
+                          </a:solidFill>
+                          <a:latin typeface="Segoe UI Semibold"/>
+                        </a:rPr>
+                        <a:t>Missing Component</a:t>
+                      </a:r>
+                    </a:p>
+                  </a:txBody>
+                  <a:tcPr marL="101600" marR="101600" marT="50800" marB="50800" anchor="ctr">
+                    <a:solidFill>
+                      <a:srgbClr val="D1495B"/>
+                    </a:solidFill>
+                  </a:tcPr>
+                </a:tc>
+                <a:tc>
+                  <a:txBody>
+                    <a:bodyPr wrap="square"/>
+                    <a:lstStyle/>
+                    <a:p>
+                      <a:pPr algn="l">
+                        <a:lnSpc>
+                          <a:spcPct val="100000"/>
+                        </a:lnSpc>
+                      </a:pPr>
+                      <a:r>
+                        <a:rPr sz="1700" b="1">
                           <a:solidFill>
                             <a:srgbClr val="FFFFFF"/>
                           </a:solidFill>
@@ -22376,7 +22686,7 @@
                   </a:tcPr>
                 </a:tc>
               </a:tr>
-              <a:tr h="786384">
+              <a:tr h="822960">
                 <a:tc>
                   <a:txBody>
                     <a:bodyPr wrap="square"/>
@@ -22388,7 +22698,7 @@
                         </a:lnSpc>
                       </a:pPr>
                       <a:r>
-                        <a:rPr sz="1800" b="0">
+                        <a:rPr sz="1550" b="0">
                           <a:solidFill>
                             <a:srgbClr val="14213D"/>
                           </a:solidFill>
@@ -22415,7 +22725,34 @@
                         </a:lnSpc>
                       </a:pPr>
                       <a:r>
-                        <a:rPr sz="1800" b="0">
+                        <a:rPr sz="1550" b="0">
+                          <a:solidFill>
+                            <a:srgbClr val="14213D"/>
+                          </a:solidFill>
+                          <a:latin typeface="Segoe UI"/>
+                        </a:rPr>
+                        <a:t>Specific problem or gap</a:t>
+                      </a:r>
+                    </a:p>
+                  </a:txBody>
+                  <a:tcPr marL="101600" marR="101600" marT="50800" marB="50800" anchor="ctr">
+                    <a:solidFill>
+                      <a:srgbClr val="F7DEE2"/>
+                    </a:solidFill>
+                  </a:tcPr>
+                </a:tc>
+                <a:tc>
+                  <a:txBody>
+                    <a:bodyPr wrap="square"/>
+                    <a:lstStyle/>
+                    <a:p>
+                      <a:pPr algn="l">
+                        <a:lnSpc>
+                          <a:spcPct val="100000"/>
+                        </a:lnSpc>
+                      </a:pPr>
+                      <a:r>
+                        <a:rPr sz="1550" b="0">
                           <a:solidFill>
                             <a:srgbClr val="14213D"/>
                           </a:solidFill>
@@ -22432,7 +22769,7 @@
                   </a:tcPr>
                 </a:tc>
               </a:tr>
-              <a:tr h="786384">
+              <a:tr h="822960">
                 <a:tc>
                   <a:txBody>
                     <a:bodyPr wrap="square"/>
@@ -22444,7 +22781,7 @@
                         </a:lnSpc>
                       </a:pPr>
                       <a:r>
-                        <a:rPr sz="1800" b="0">
+                        <a:rPr sz="1550" b="0">
                           <a:solidFill>
                             <a:srgbClr val="14213D"/>
                           </a:solidFill>
@@ -22471,24 +22808,22 @@
                         </a:lnSpc>
                       </a:pPr>
                       <a:r>
-                        <a:rPr sz="1800" b="0">
+                        <a:rPr sz="1550" b="0">
                           <a:solidFill>
                             <a:srgbClr val="14213D"/>
                           </a:solidFill>
                           <a:latin typeface="Segoe UI"/>
                         </a:rPr>
-                        <a:t>State exactly what is missing or unresolved</a:t>
+                        <a:t>Objectives or aims</a:t>
                       </a:r>
                     </a:p>
                   </a:txBody>
                   <a:tcPr marL="101600" marR="101600" marT="50800" marB="50800" anchor="ctr">
                     <a:solidFill>
-                      <a:srgbClr val="EEF4F7"/>
+                      <a:srgbClr val="F7DEE2"/>
                     </a:solidFill>
                   </a:tcPr>
                 </a:tc>
-              </a:tr>
-              <a:tr h="786384">
                 <a:tc>
                   <a:txBody>
                     <a:bodyPr wrap="square"/>
@@ -22500,7 +22835,36 @@
                         </a:lnSpc>
                       </a:pPr>
                       <a:r>
-                        <a:rPr sz="1800" b="0">
+                        <a:rPr sz="1550" b="0">
+                          <a:solidFill>
+                            <a:srgbClr val="14213D"/>
+                          </a:solidFill>
+                          <a:latin typeface="Segoe UI"/>
+                        </a:rPr>
+                        <a:t>State exactly what the study will investigate or accomplish</a:t>
+                      </a:r>
+                    </a:p>
+                  </a:txBody>
+                  <a:tcPr marL="101600" marR="101600" marT="50800" marB="50800" anchor="ctr">
+                    <a:solidFill>
+                      <a:srgbClr val="EEF4F7"/>
+                    </a:solidFill>
+                  </a:tcPr>
+                </a:tc>
+              </a:tr>
+              <a:tr h="822960">
+                <a:tc>
+                  <a:txBody>
+                    <a:bodyPr wrap="square"/>
+                    <a:lstStyle/>
+                    <a:p>
+                      <a:pPr algn="l">
+                        <a:lnSpc>
+                          <a:spcPct val="100000"/>
+                        </a:lnSpc>
+                      </a:pPr>
+                      <a:r>
+                        <a:rPr sz="1550" b="0">
                           <a:solidFill>
                             <a:srgbClr val="14213D"/>
                           </a:solidFill>
@@ -22527,7 +22891,34 @@
                         </a:lnSpc>
                       </a:pPr>
                       <a:r>
-                        <a:rPr sz="1800" b="0">
+                        <a:rPr sz="1550" b="0">
+                          <a:solidFill>
+                            <a:srgbClr val="14213D"/>
+                          </a:solidFill>
+                          <a:latin typeface="Segoe UI"/>
+                        </a:rPr>
+                        <a:t>Implications</a:t>
+                      </a:r>
+                    </a:p>
+                  </a:txBody>
+                  <a:tcPr marL="101600" marR="101600" marT="50800" marB="50800" anchor="ctr">
+                    <a:solidFill>
+                      <a:srgbClr val="F7DEE2"/>
+                    </a:solidFill>
+                  </a:tcPr>
+                </a:tc>
+                <a:tc>
+                  <a:txBody>
+                    <a:bodyPr wrap="square"/>
+                    <a:lstStyle/>
+                    <a:p>
+                      <a:pPr algn="l">
+                        <a:lnSpc>
+                          <a:spcPct val="100000"/>
+                        </a:lnSpc>
+                      </a:pPr>
+                      <a:r>
+                        <a:rPr sz="1550" b="0">
                           <a:solidFill>
                             <a:srgbClr val="14213D"/>
                           </a:solidFill>
@@ -22544,7 +22935,7 @@
                   </a:tcPr>
                 </a:tc>
               </a:tr>
-              <a:tr h="786384">
+              <a:tr h="822960">
                 <a:tc>
                   <a:txBody>
                     <a:bodyPr wrap="square"/>
@@ -22556,7 +22947,7 @@
                         </a:lnSpc>
                       </a:pPr>
                       <a:r>
-                        <a:rPr sz="1800" b="0">
+                        <a:rPr sz="1550" b="0">
                           <a:solidFill>
                             <a:srgbClr val="14213D"/>
                           </a:solidFill>
@@ -22583,7 +22974,34 @@
                         </a:lnSpc>
                       </a:pPr>
                       <a:r>
-                        <a:rPr sz="1800" b="0">
+                        <a:rPr sz="1550" b="0">
+                          <a:solidFill>
+                            <a:srgbClr val="14213D"/>
+                          </a:solidFill>
+                          <a:latin typeface="Segoe UI"/>
+                        </a:rPr>
+                        <a:t>Specific problem or gap</a:t>
+                      </a:r>
+                    </a:p>
+                  </a:txBody>
+                  <a:tcPr marL="101600" marR="101600" marT="50800" marB="50800" anchor="ctr">
+                    <a:solidFill>
+                      <a:srgbClr val="F7DEE2"/>
+                    </a:solidFill>
+                  </a:tcPr>
+                </a:tc>
+                <a:tc>
+                  <a:txBody>
+                    <a:bodyPr wrap="square"/>
+                    <a:lstStyle/>
+                    <a:p>
+                      <a:pPr algn="l">
+                        <a:lnSpc>
+                          <a:spcPct val="100000"/>
+                        </a:lnSpc>
+                      </a:pPr>
+                      <a:r>
+                        <a:rPr sz="1550" b="0">
                           <a:solidFill>
                             <a:srgbClr val="14213D"/>
                           </a:solidFill>
@@ -23667,7 +24085,7 @@
                 </a:solidFill>
                 <a:latin typeface="Segoe UI Semibold"/>
               </a:rPr>
-              <a:t>In pairs: name the pitfall, then rewrite using the Context – Relevance – Strategy formula.</a:t>
+              <a:t>In pairs: name the missing component, then rewrite with one sentence per component (Slide 24).</a:t>
             </a:r>
           </a:p>
         </p:txBody>

</xml_diff>